<commit_message>
Lessons: glossary entries for embedded DB/SST/EV, scope the one-endpoint figure subtitle
Co-Authored-By: Claude Opus 5.5 <noreply@anthropic.com>
Claude-Session: https://claude.ai/code/session_01McBLtMnJbTnB94NeVs8a2V
</commit_message>
<xml_diff>
--- a/system-design-101/vi/lessons/sd-02-029/slides/sd-02-029.pptx
+++ b/system-design-101/vi/lessons/sd-02-029/slides/sd-02-029.pptx
@@ -2891,7 +2891,7 @@
           </p:nvPr>
         </p:nvGraphicFramePr>
         <p:xfrm>
-          <a:off x="914400" y="2476500"/>
+          <a:off x="914400" y="2381250"/>
           <a:ext cx="13716000" cy="914400"/>
         </p:xfrm>
         <a:graphic>
@@ -2903,7 +2903,7 @@
                 <a:gridCol w="6254496"/>
                 <a:gridCol w="7900416"/>
               </a:tblGrid>
-              <a:tr h="990600">
+              <a:tr h="800100">
                 <a:tc>
                   <a:txBody>
                     <a:bodyPr/>
@@ -3102,7 +3102,7 @@
                   </a:tcPr>
                 </a:tc>
               </a:tr>
-              <a:tr h="990600">
+              <a:tr h="800100">
                 <a:tc>
                   <a:txBody>
                     <a:bodyPr/>
@@ -3352,7 +3352,7 @@
                   </a:tcPr>
                 </a:tc>
               </a:tr>
-              <a:tr h="990600">
+              <a:tr h="800100">
                 <a:tc>
                   <a:txBody>
                     <a:bodyPr/>
@@ -3591,7 +3591,7 @@
                   </a:tcPr>
                 </a:tc>
               </a:tr>
-              <a:tr h="990600">
+              <a:tr h="800100">
                 <a:tc>
                   <a:txBody>
                     <a:bodyPr/>
@@ -3863,6 +3863,495 @@
                   </a:tcPr>
                 </a:tc>
               </a:tr>
+              <a:tr h="800100">
+                <a:tc>
+                  <a:txBody>
+                    <a:bodyPr/>
+                    <a:lstStyle/>
+                    <a:p>
+                      <a:pPr algn="l" indent="0" marL="0">
+                        <a:lnSpc>
+                          <a:spcPts val="2700"/>
+                        </a:lnSpc>
+                        <a:buNone/>
+                      </a:pPr>
+                      <a:r>
+                        <a:rPr lang="en-US" sz="2250" dirty="0" spc="2" kern="0">
+                          <a:solidFill>
+                            <a:srgbClr val="3DD6A0"/>
+                          </a:solidFill>
+                          <a:latin typeface="Be Vietnam Pro" pitchFamily="34" charset="0"/>
+                          <a:ea typeface="Be Vietnam Pro" pitchFamily="34" charset="-122"/>
+                          <a:cs typeface="Be Vietnam Pro" pitchFamily="34" charset="-120"/>
+                        </a:rPr>
+                        <a:t>DB</a:t>
+                      </a:r>
+                      <a:endParaRPr lang="en-US" sz="1200" dirty="0"/>
+                    </a:p>
+                  </a:txBody>
+                  <a:tcPr marL="76200" marR="76200" marT="76200" marB="76200">
+                    <a:lnL w="9525" cap="flat" cmpd="sng" algn="ctr">
+                      <a:solidFill>
+                        <a:srgbClr val="2D3140"/>
+                      </a:solidFill>
+                      <a:prstDash val="solid"/>
+                      <a:round/>
+                      <a:headEnd type="none" w="med" len="med"/>
+                      <a:tailEnd type="none" w="med" len="med"/>
+                    </a:lnL>
+                    <a:lnR w="0" cap="flat" cmpd="sng" algn="ctr">
+                      <a:noFill/>
+                    </a:lnR>
+                    <a:lnT w="9525" cap="flat" cmpd="sng" algn="ctr">
+                      <a:solidFill>
+                        <a:srgbClr val="2D3140"/>
+                      </a:solidFill>
+                      <a:prstDash val="solid"/>
+                      <a:round/>
+                      <a:headEnd type="none" w="med" len="med"/>
+                      <a:tailEnd type="none" w="med" len="med"/>
+                    </a:lnT>
+                    <a:lnB w="0" cap="flat" cmpd="sng" algn="ctr">
+                      <a:noFill/>
+                    </a:lnB>
+                    <a:solidFill>
+                      <a:srgbClr val="14161C"/>
+                    </a:solidFill>
+                  </a:tcPr>
+                </a:tc>
+                <a:tc>
+                  <a:txBody>
+                    <a:bodyPr/>
+                    <a:lstStyle/>
+                    <a:p>
+                      <a:pPr algn="l" indent="0" marL="0">
+                        <a:lnSpc>
+                          <a:spcPts val="2700"/>
+                        </a:lnSpc>
+                        <a:buNone/>
+                      </a:pPr>
+                      <a:r>
+                        <a:rPr lang="en-US" sz="2250" dirty="0" spc="-15" kern="0">
+                          <a:solidFill>
+                            <a:srgbClr val="E4E1D8"/>
+                          </a:solidFill>
+                          <a:latin typeface="Be Vietnam Pro" pitchFamily="34" charset="0"/>
+                          <a:ea typeface="Be Vietnam Pro" pitchFamily="34" charset="-122"/>
+                          <a:cs typeface="Be Vietnam Pro" pitchFamily="34" charset="-120"/>
+                        </a:rPr>
+                        <a:t>DataBase</a:t>
+                      </a:r>
+                      <a:endParaRPr lang="en-US" sz="1200" dirty="0"/>
+                    </a:p>
+                  </a:txBody>
+                  <a:tcPr marL="76200" marR="76200" marT="76200" marB="76200">
+                    <a:lnL w="9525" cap="flat" cmpd="sng" algn="ctr">
+                      <a:solidFill>
+                        <a:srgbClr val="2D3140"/>
+                      </a:solidFill>
+                      <a:prstDash val="solid"/>
+                      <a:round/>
+                      <a:headEnd type="none" w="med" len="med"/>
+                      <a:tailEnd type="none" w="med" len="med"/>
+                    </a:lnL>
+                    <a:lnR w="0" cap="flat" cmpd="sng" algn="ctr">
+                      <a:noFill/>
+                    </a:lnR>
+                    <a:lnT w="9525" cap="flat" cmpd="sng" algn="ctr">
+                      <a:solidFill>
+                        <a:srgbClr val="2D3140"/>
+                      </a:solidFill>
+                      <a:prstDash val="solid"/>
+                      <a:round/>
+                      <a:headEnd type="none" w="med" len="med"/>
+                      <a:tailEnd type="none" w="med" len="med"/>
+                    </a:lnT>
+                    <a:lnB w="0" cap="flat" cmpd="sng" algn="ctr">
+                      <a:noFill/>
+                    </a:lnB>
+                    <a:solidFill>
+                      <a:srgbClr val="14161C"/>
+                    </a:solidFill>
+                  </a:tcPr>
+                </a:tc>
+                <a:tc>
+                  <a:txBody>
+                    <a:bodyPr/>
+                    <a:lstStyle/>
+                    <a:p>
+                      <a:pPr algn="l" indent="0" marL="0">
+                        <a:lnSpc>
+                          <a:spcPts val="2700"/>
+                        </a:lnSpc>
+                        <a:buNone/>
+                      </a:pPr>
+                      <a:r>
+                        <a:rPr lang="en-US" sz="2250" dirty="0" spc="-1" kern="0">
+                          <a:solidFill>
+                            <a:srgbClr val="E4E1D8"/>
+                          </a:solidFill>
+                          <a:latin typeface="Be Vietnam Pro" pitchFamily="34" charset="0"/>
+                          <a:ea typeface="Be Vietnam Pro" pitchFamily="34" charset="-122"/>
+                          <a:cs typeface="Be Vietnam Pro" pitchFamily="34" charset="-120"/>
+                        </a:rPr>
+                        <a:t>cơ</a:t>
+                      </a:r>
+                      <a:r>
+                        <a:rPr lang="en-US" sz="2250" dirty="0" spc="-2" kern="0">
+                          <a:solidFill>
+                            <a:srgbClr val="E4E1D8"/>
+                          </a:solidFill>
+                          <a:latin typeface="Be Vietnam Pro" pitchFamily="34" charset="0"/>
+                          <a:ea typeface="Be Vietnam Pro" pitchFamily="34" charset="-122"/>
+                          <a:cs typeface="Be Vietnam Pro" pitchFamily="34" charset="-120"/>
+                        </a:rPr>
+                        <a:t> sở</a:t>
+                      </a:r>
+                      <a:r>
+                        <a:rPr lang="en-US" sz="2250" dirty="0" spc="4" kern="0">
+                          <a:solidFill>
+                            <a:srgbClr val="E4E1D8"/>
+                          </a:solidFill>
+                          <a:latin typeface="Be Vietnam Pro" pitchFamily="34" charset="0"/>
+                          <a:ea typeface="Be Vietnam Pro" pitchFamily="34" charset="-122"/>
+                          <a:cs typeface="Be Vietnam Pro" pitchFamily="34" charset="-120"/>
+                        </a:rPr>
+                        <a:t> dữ</a:t>
+                      </a:r>
+                      <a:r>
+                        <a:rPr lang="en-US" sz="2250" dirty="0" spc="-2" kern="0">
+                          <a:solidFill>
+                            <a:srgbClr val="E4E1D8"/>
+                          </a:solidFill>
+                          <a:latin typeface="Be Vietnam Pro" pitchFamily="34" charset="0"/>
+                          <a:ea typeface="Be Vietnam Pro" pitchFamily="34" charset="-122"/>
+                          <a:cs typeface="Be Vietnam Pro" pitchFamily="34" charset="-120"/>
+                        </a:rPr>
+                        <a:t> liệu,</a:t>
+                      </a:r>
+                      <a:r>
+                        <a:rPr lang="en-US" sz="2250" dirty="0" spc="-16" kern="0">
+                          <a:solidFill>
+                            <a:srgbClr val="E4E1D8"/>
+                          </a:solidFill>
+                          <a:latin typeface="Be Vietnam Pro" pitchFamily="34" charset="0"/>
+                          <a:ea typeface="Be Vietnam Pro" pitchFamily="34" charset="-122"/>
+                          <a:cs typeface="Be Vietnam Pro" pitchFamily="34" charset="-120"/>
+                        </a:rPr>
+                        <a:t> trong</a:t>
+                      </a:r>
+                      <a:r>
+                        <a:rPr lang="en-US" sz="2250" dirty="0" spc="-7" kern="0">
+                          <a:solidFill>
+                            <a:srgbClr val="E4E1D8"/>
+                          </a:solidFill>
+                          <a:latin typeface="Be Vietnam Pro" pitchFamily="34" charset="0"/>
+                          <a:ea typeface="Be Vietnam Pro" pitchFamily="34" charset="-122"/>
+                          <a:cs typeface="Be Vietnam Pro" pitchFamily="34" charset="-120"/>
+                        </a:rPr>
+                        <a:t> MongoDB,</a:t>
+                      </a:r>
+                      <a:r>
+                        <a:rPr lang="en-US" sz="2250" dirty="0" spc="-6" kern="0">
+                          <a:solidFill>
+                            <a:srgbClr val="E4E1D8"/>
+                          </a:solidFill>
+                          <a:latin typeface="Be Vietnam Pro" pitchFamily="34" charset="0"/>
+                          <a:ea typeface="Be Vietnam Pro" pitchFamily="34" charset="-122"/>
+                          <a:cs typeface="Be Vietnam Pro" pitchFamily="34" charset="-120"/>
+                        </a:rPr>
+                        <a:t> ScyllaDB</a:t>
+                      </a:r>
+                      <a:endParaRPr lang="en-US" sz="1200" dirty="0"/>
+                    </a:p>
+                  </a:txBody>
+                  <a:tcPr marL="76200" marR="76200" marT="76200" marB="76200">
+                    <a:lnL w="9525" cap="flat" cmpd="sng" algn="ctr">
+                      <a:solidFill>
+                        <a:srgbClr val="2D3140"/>
+                      </a:solidFill>
+                      <a:prstDash val="solid"/>
+                      <a:round/>
+                      <a:headEnd type="none" w="med" len="med"/>
+                      <a:tailEnd type="none" w="med" len="med"/>
+                    </a:lnL>
+                    <a:lnR w="9525" cap="flat" cmpd="sng" algn="ctr">
+                      <a:solidFill>
+                        <a:srgbClr val="2D3140"/>
+                      </a:solidFill>
+                      <a:prstDash val="solid"/>
+                      <a:round/>
+                      <a:headEnd type="none" w="med" len="med"/>
+                      <a:tailEnd type="none" w="med" len="med"/>
+                    </a:lnR>
+                    <a:lnT w="9525" cap="flat" cmpd="sng" algn="ctr">
+                      <a:solidFill>
+                        <a:srgbClr val="2D3140"/>
+                      </a:solidFill>
+                      <a:prstDash val="solid"/>
+                      <a:round/>
+                      <a:headEnd type="none" w="med" len="med"/>
+                      <a:tailEnd type="none" w="med" len="med"/>
+                    </a:lnT>
+                    <a:lnB w="0" cap="flat" cmpd="sng" algn="ctr">
+                      <a:noFill/>
+                    </a:lnB>
+                    <a:solidFill>
+                      <a:srgbClr val="14161C"/>
+                    </a:solidFill>
+                  </a:tcPr>
+                </a:tc>
+              </a:tr>
+              <a:tr h="800100">
+                <a:tc>
+                  <a:txBody>
+                    <a:bodyPr/>
+                    <a:lstStyle/>
+                    <a:p>
+                      <a:pPr algn="l" indent="0" marL="0">
+                        <a:lnSpc>
+                          <a:spcPts val="2700"/>
+                        </a:lnSpc>
+                        <a:buNone/>
+                      </a:pPr>
+                      <a:r>
+                        <a:rPr lang="en-US" sz="2250" dirty="0" spc="-12" kern="0">
+                          <a:solidFill>
+                            <a:srgbClr val="3DD6A0"/>
+                          </a:solidFill>
+                          <a:latin typeface="Be Vietnam Pro" pitchFamily="34" charset="0"/>
+                          <a:ea typeface="Be Vietnam Pro" pitchFamily="34" charset="-122"/>
+                          <a:cs typeface="Be Vietnam Pro" pitchFamily="34" charset="-120"/>
+                        </a:rPr>
+                        <a:t>SST</a:t>
+                      </a:r>
+                      <a:endParaRPr lang="en-US" sz="1200" dirty="0"/>
+                    </a:p>
+                  </a:txBody>
+                  <a:tcPr marL="76200" marR="76200" marT="76200" marB="76200">
+                    <a:lnL w="9525" cap="flat" cmpd="sng" algn="ctr">
+                      <a:solidFill>
+                        <a:srgbClr val="2D3140"/>
+                      </a:solidFill>
+                      <a:prstDash val="solid"/>
+                      <a:round/>
+                      <a:headEnd type="none" w="med" len="med"/>
+                      <a:tailEnd type="none" w="med" len="med"/>
+                    </a:lnL>
+                    <a:lnR w="0" cap="flat" cmpd="sng" algn="ctr">
+                      <a:noFill/>
+                    </a:lnR>
+                    <a:lnT w="9525" cap="flat" cmpd="sng" algn="ctr">
+                      <a:solidFill>
+                        <a:srgbClr val="2D3140"/>
+                      </a:solidFill>
+                      <a:prstDash val="solid"/>
+                      <a:round/>
+                      <a:headEnd type="none" w="med" len="med"/>
+                      <a:tailEnd type="none" w="med" len="med"/>
+                    </a:lnT>
+                    <a:lnB w="0" cap="flat" cmpd="sng" algn="ctr">
+                      <a:noFill/>
+                    </a:lnB>
+                    <a:solidFill>
+                      <a:srgbClr val="1A1D25"/>
+                    </a:solidFill>
+                  </a:tcPr>
+                </a:tc>
+                <a:tc>
+                  <a:txBody>
+                    <a:bodyPr/>
+                    <a:lstStyle/>
+                    <a:p>
+                      <a:pPr algn="l" indent="0" marL="0">
+                        <a:lnSpc>
+                          <a:spcPts val="2700"/>
+                        </a:lnSpc>
+                        <a:buNone/>
+                      </a:pPr>
+                      <a:r>
+                        <a:rPr lang="en-US" sz="2250" dirty="0" spc="-10" kern="0">
+                          <a:solidFill>
+                            <a:srgbClr val="E4E1D8"/>
+                          </a:solidFill>
+                          <a:latin typeface="Be Vietnam Pro" pitchFamily="34" charset="0"/>
+                          <a:ea typeface="Be Vietnam Pro" pitchFamily="34" charset="-122"/>
+                          <a:cs typeface="Be Vietnam Pro" pitchFamily="34" charset="-120"/>
+                        </a:rPr>
+                        <a:t>Sorted</a:t>
+                      </a:r>
+                      <a:r>
+                        <a:rPr lang="en-US" sz="2250" dirty="0" spc="6" kern="0">
+                          <a:solidFill>
+                            <a:srgbClr val="E4E1D8"/>
+                          </a:solidFill>
+                          <a:latin typeface="Be Vietnam Pro" pitchFamily="34" charset="0"/>
+                          <a:ea typeface="Be Vietnam Pro" pitchFamily="34" charset="-122"/>
+                          <a:cs typeface="Be Vietnam Pro" pitchFamily="34" charset="-120"/>
+                        </a:rPr>
+                        <a:t> String</a:t>
+                      </a:r>
+                      <a:r>
+                        <a:rPr lang="en-US" sz="2250" dirty="0" spc="-34" kern="0">
+                          <a:solidFill>
+                            <a:srgbClr val="E4E1D8"/>
+                          </a:solidFill>
+                          <a:latin typeface="Be Vietnam Pro" pitchFamily="34" charset="0"/>
+                          <a:ea typeface="Be Vietnam Pro" pitchFamily="34" charset="-122"/>
+                          <a:cs typeface="Be Vietnam Pro" pitchFamily="34" charset="-120"/>
+                        </a:rPr>
+                        <a:t> Table</a:t>
+                      </a:r>
+                      <a:endParaRPr lang="en-US" sz="1200" dirty="0"/>
+                    </a:p>
+                  </a:txBody>
+                  <a:tcPr marL="76200" marR="76200" marT="76200" marB="76200">
+                    <a:lnL w="9525" cap="flat" cmpd="sng" algn="ctr">
+                      <a:solidFill>
+                        <a:srgbClr val="2D3140"/>
+                      </a:solidFill>
+                      <a:prstDash val="solid"/>
+                      <a:round/>
+                      <a:headEnd type="none" w="med" len="med"/>
+                      <a:tailEnd type="none" w="med" len="med"/>
+                    </a:lnL>
+                    <a:lnR w="0" cap="flat" cmpd="sng" algn="ctr">
+                      <a:noFill/>
+                    </a:lnR>
+                    <a:lnT w="9525" cap="flat" cmpd="sng" algn="ctr">
+                      <a:solidFill>
+                        <a:srgbClr val="2D3140"/>
+                      </a:solidFill>
+                      <a:prstDash val="solid"/>
+                      <a:round/>
+                      <a:headEnd type="none" w="med" len="med"/>
+                      <a:tailEnd type="none" w="med" len="med"/>
+                    </a:lnT>
+                    <a:lnB w="0" cap="flat" cmpd="sng" algn="ctr">
+                      <a:noFill/>
+                    </a:lnB>
+                    <a:solidFill>
+                      <a:srgbClr val="1A1D25"/>
+                    </a:solidFill>
+                  </a:tcPr>
+                </a:tc>
+                <a:tc>
+                  <a:txBody>
+                    <a:bodyPr/>
+                    <a:lstStyle/>
+                    <a:p>
+                      <a:pPr algn="l" indent="0" marL="0">
+                        <a:lnSpc>
+                          <a:spcPts val="2700"/>
+                        </a:lnSpc>
+                        <a:buNone/>
+                      </a:pPr>
+                      <a:r>
+                        <a:rPr lang="en-US" sz="2250" dirty="0" spc="-15" kern="0">
+                          <a:solidFill>
+                            <a:srgbClr val="E4E1D8"/>
+                          </a:solidFill>
+                          <a:latin typeface="Be Vietnam Pro" pitchFamily="34" charset="0"/>
+                          <a:ea typeface="Be Vietnam Pro" pitchFamily="34" charset="-122"/>
+                          <a:cs typeface="Be Vietnam Pro" pitchFamily="34" charset="-120"/>
+                        </a:rPr>
+                        <a:t>tệp</a:t>
+                      </a:r>
+                      <a:r>
+                        <a:rPr lang="en-US" sz="2250" dirty="0" spc="-2" kern="0">
+                          <a:solidFill>
+                            <a:srgbClr val="E4E1D8"/>
+                          </a:solidFill>
+                          <a:latin typeface="Be Vietnam Pro" pitchFamily="34" charset="0"/>
+                          <a:ea typeface="Be Vietnam Pro" pitchFamily="34" charset="-122"/>
+                          <a:cs typeface="Be Vietnam Pro" pitchFamily="34" charset="-120"/>
+                        </a:rPr>
+                        <a:t> khóa</a:t>
+                      </a:r>
+                      <a:r>
+                        <a:rPr lang="en-US" sz="2250" dirty="0" spc="16" kern="0">
+                          <a:solidFill>
+                            <a:srgbClr val="E4E1D8"/>
+                          </a:solidFill>
+                          <a:latin typeface="Be Vietnam Pro" pitchFamily="34" charset="0"/>
+                          <a:ea typeface="Be Vietnam Pro" pitchFamily="34" charset="-122"/>
+                          <a:cs typeface="Be Vietnam Pro" pitchFamily="34" charset="-120"/>
+                        </a:rPr>
+                        <a:t> đã</a:t>
+                      </a:r>
+                      <a:r>
+                        <a:rPr lang="en-US" sz="2250" dirty="0" spc="-4" kern="0">
+                          <a:solidFill>
+                            <a:srgbClr val="E4E1D8"/>
+                          </a:solidFill>
+                          <a:latin typeface="Be Vietnam Pro" pitchFamily="34" charset="0"/>
+                          <a:ea typeface="Be Vietnam Pro" pitchFamily="34" charset="-122"/>
+                          <a:cs typeface="Be Vietnam Pro" pitchFamily="34" charset="-120"/>
+                        </a:rPr>
+                        <a:t> sắp</a:t>
+                      </a:r>
+                      <a:r>
+                        <a:rPr lang="en-US" sz="2250" dirty="0" spc="-16" kern="0">
+                          <a:solidFill>
+                            <a:srgbClr val="E4E1D8"/>
+                          </a:solidFill>
+                          <a:latin typeface="Be Vietnam Pro" pitchFamily="34" charset="0"/>
+                          <a:ea typeface="Be Vietnam Pro" pitchFamily="34" charset="-122"/>
+                          <a:cs typeface="Be Vietnam Pro" pitchFamily="34" charset="-120"/>
+                        </a:rPr>
+                        <a:t> xếp</a:t>
+                      </a:r>
+                      <a:r>
+                        <a:rPr lang="en-US" sz="2250" dirty="0" spc="-24" kern="0">
+                          <a:solidFill>
+                            <a:srgbClr val="E4E1D8"/>
+                          </a:solidFill>
+                          <a:latin typeface="Be Vietnam Pro" pitchFamily="34" charset="0"/>
+                          <a:ea typeface="Be Vietnam Pro" pitchFamily="34" charset="-122"/>
+                          <a:cs typeface="Be Vietnam Pro" pitchFamily="34" charset="-120"/>
+                        </a:rPr>
+                        <a:t> (SSTable)</a:t>
+                      </a:r>
+                      <a:endParaRPr lang="en-US" sz="1200" dirty="0"/>
+                    </a:p>
+                  </a:txBody>
+                  <a:tcPr marL="76200" marR="76200" marT="76200" marB="76200">
+                    <a:lnL w="9525" cap="flat" cmpd="sng" algn="ctr">
+                      <a:solidFill>
+                        <a:srgbClr val="2D3140"/>
+                      </a:solidFill>
+                      <a:prstDash val="solid"/>
+                      <a:round/>
+                      <a:headEnd type="none" w="med" len="med"/>
+                      <a:tailEnd type="none" w="med" len="med"/>
+                    </a:lnL>
+                    <a:lnR w="9525" cap="flat" cmpd="sng" algn="ctr">
+                      <a:solidFill>
+                        <a:srgbClr val="2D3140"/>
+                      </a:solidFill>
+                      <a:prstDash val="solid"/>
+                      <a:round/>
+                      <a:headEnd type="none" w="med" len="med"/>
+                      <a:tailEnd type="none" w="med" len="med"/>
+                    </a:lnR>
+                    <a:lnT w="9525" cap="flat" cmpd="sng" algn="ctr">
+                      <a:solidFill>
+                        <a:srgbClr val="2D3140"/>
+                      </a:solidFill>
+                      <a:prstDash val="solid"/>
+                      <a:round/>
+                      <a:headEnd type="none" w="med" len="med"/>
+                      <a:tailEnd type="none" w="med" len="med"/>
+                    </a:lnT>
+                    <a:lnB w="0" cap="flat" cmpd="sng" algn="ctr">
+                      <a:noFill/>
+                    </a:lnB>
+                    <a:solidFill>
+                      <a:srgbClr val="1A1D25"/>
+                    </a:solidFill>
+                  </a:tcPr>
+                </a:tc>
+              </a:tr>
             </a:tbl>
           </a:graphicData>
         </a:graphic>
@@ -3875,7 +4364,7 @@
         </p:nvSpPr>
         <p:spPr>
           <a:xfrm>
-            <a:off x="914400" y="6915150"/>
+            <a:off x="914400" y="7677150"/>
             <a:ext cx="11430000" cy="428625"/>
           </a:xfrm>
           <a:prstGeom prst="rect">
@@ -3925,7 +4414,7 @@
         </p:nvSpPr>
         <p:spPr>
           <a:xfrm>
-            <a:off x="914400" y="7334250"/>
+            <a:off x="914400" y="8096250"/>
             <a:ext cx="16459200" cy="552450"/>
           </a:xfrm>
           <a:prstGeom prst="rect">
@@ -4041,7 +4530,7 @@
         </p:nvSpPr>
         <p:spPr>
           <a:xfrm>
-            <a:off x="914400" y="7867650"/>
+            <a:off x="914400" y="8629650"/>
             <a:ext cx="16459200" cy="390525"/>
           </a:xfrm>
           <a:prstGeom prst="rect">

</xml_diff>

<commit_message>
sd-02-029/031/032: commit log in the write path, no invented gateway roles, no runtime split or tool roles for Netflix
Co-Authored-By: Claude Opus 5.5 <noreply@anthropic.com>
Claude-Session: https://claude.ai/code/session_01McBLtMnJbTnB94NeVs8a2V
</commit_message>
<xml_diff>
--- a/system-design-101/vi/lessons/sd-02-029/slides/sd-02-029.pptx
+++ b/system-design-101/vi/lessons/sd-02-029/slides/sd-02-029.pptx
@@ -13031,7 +13031,7 @@
               <a:buNone/>
             </a:pPr>
             <a:r>
-              <a:rPr lang="en-US" sz="2850" b="1" dirty="0" spc="-5" kern="0">
+              <a:rPr lang="en-US" sz="2850" b="1" dirty="0" spc="-12" kern="0">
                 <a:solidFill>
                   <a:srgbClr val="F3EEE3"/>
                 </a:solidFill>
@@ -13039,7 +13039,62 @@
                 <a:ea typeface="Be Vietnam Pro" pitchFamily="34" charset="-122"/>
                 <a:cs typeface="Be Vietnam Pro" pitchFamily="34" charset="-120"/>
               </a:rPr>
-              <a:t>Nối thêm,</a:t>
+              <a:t>Nhật</a:t>
+            </a:r>
+            <a:r>
+              <a:rPr lang="en-US" sz="2850" b="1" dirty="0" spc="1" kern="0">
+                <a:solidFill>
+                  <a:srgbClr val="F3EEE3"/>
+                </a:solidFill>
+                <a:latin typeface="Be Vietnam Pro" pitchFamily="34" charset="0"/>
+                <a:ea typeface="Be Vietnam Pro" pitchFamily="34" charset="-122"/>
+                <a:cs typeface="Be Vietnam Pro" pitchFamily="34" charset="-120"/>
+              </a:rPr>
+              <a:t> ký</a:t>
+            </a:r>
+            <a:r>
+              <a:rPr lang="en-US" sz="2850" b="1" dirty="0" spc="-15" kern="0">
+                <a:solidFill>
+                  <a:srgbClr val="F3EEE3"/>
+                </a:solidFill>
+                <a:latin typeface="Be Vietnam Pro" pitchFamily="34" charset="0"/>
+                <a:ea typeface="Be Vietnam Pro" pitchFamily="34" charset="-122"/>
+                <a:cs typeface="Be Vietnam Pro" pitchFamily="34" charset="-120"/>
+              </a:rPr>
+              <a:t> trên</a:t>
+            </a:r>
+            <a:r>
+              <a:rPr lang="en-US" sz="2850" b="1" dirty="0" spc="18" kern="0">
+                <a:solidFill>
+                  <a:srgbClr val="F3EEE3"/>
+                </a:solidFill>
+                <a:latin typeface="Be Vietnam Pro" pitchFamily="34" charset="0"/>
+                <a:ea typeface="Be Vietnam Pro" pitchFamily="34" charset="-122"/>
+                <a:cs typeface="Be Vietnam Pro" pitchFamily="34" charset="-120"/>
+              </a:rPr>
+              <a:t> đĩa</a:t>
+            </a:r>
+            <a:r>
+              <a:rPr lang="en-US" sz="2850" b="1" dirty="0" spc="-20" kern="0">
+                <a:solidFill>
+                  <a:srgbClr val="F3EEE3"/>
+                </a:solidFill>
+                <a:latin typeface="Be Vietnam Pro" pitchFamily="34" charset="0"/>
+                <a:ea typeface="Be Vietnam Pro" pitchFamily="34" charset="-122"/>
+                <a:cs typeface="Be Vietnam Pro" pitchFamily="34" charset="-120"/>
+              </a:rPr>
+              <a:t> và</a:t>
+            </a:r>
+            <a:r>
+              <a:rPr lang="en-US" sz="2850" b="1" dirty="0" spc="-1" kern="0">
+                <a:solidFill>
+                  <a:srgbClr val="F3EEE3"/>
+                </a:solidFill>
+                <a:latin typeface="Be Vietnam Pro" pitchFamily="34" charset="0"/>
+                <a:ea typeface="Be Vietnam Pro" pitchFamily="34" charset="-122"/>
+                <a:cs typeface="Be Vietnam Pro" pitchFamily="34" charset="-120"/>
+              </a:rPr>
+              <a:t> bảng</a:t>
             </a:r>
             <a:r>
               <a:rPr lang="en-US" sz="2850" b="1" dirty="0" spc="-14" kern="0">
@@ -13050,6 +13105,39 @@
                 <a:ea typeface="Be Vietnam Pro" pitchFamily="34" charset="-122"/>
                 <a:cs typeface="Be Vietnam Pro" pitchFamily="34" charset="-120"/>
               </a:rPr>
+              <a:t> trong</a:t>
+            </a:r>
+            <a:r>
+              <a:rPr lang="en-US" sz="2850" b="1" dirty="0" spc="-2" kern="0">
+                <a:solidFill>
+                  <a:srgbClr val="F3EEE3"/>
+                </a:solidFill>
+                <a:latin typeface="Be Vietnam Pro" pitchFamily="34" charset="0"/>
+                <a:ea typeface="Be Vietnam Pro" pitchFamily="34" charset="-122"/>
+                <a:cs typeface="Be Vietnam Pro" pitchFamily="34" charset="-120"/>
+              </a:rPr>
+              <a:t> bộ</a:t>
+            </a:r>
+            <a:r>
+              <a:rPr lang="en-US" sz="2850" b="1" dirty="0" spc="-3" kern="0">
+                <a:solidFill>
+                  <a:srgbClr val="F3EEE3"/>
+                </a:solidFill>
+                <a:latin typeface="Be Vietnam Pro" pitchFamily="34" charset="0"/>
+                <a:ea typeface="Be Vietnam Pro" pitchFamily="34" charset="-122"/>
+                <a:cs typeface="Be Vietnam Pro" pitchFamily="34" charset="-120"/>
+              </a:rPr>
+              <a:t> nhớ,</a:t>
+            </a:r>
+            <a:r>
+              <a:rPr lang="en-US" sz="2850" b="1" dirty="0" spc="-13" kern="0">
+                <a:solidFill>
+                  <a:srgbClr val="F3EEE3"/>
+                </a:solidFill>
+                <a:latin typeface="Be Vietnam Pro" pitchFamily="34" charset="0"/>
+                <a:ea typeface="Be Vietnam Pro" pitchFamily="34" charset="-122"/>
+                <a:cs typeface="Be Vietnam Pro" pitchFamily="34" charset="-120"/>
+              </a:rPr>
               <a:t> rồi</a:t>
             </a:r>
             <a:r>
@@ -13084,17 +13172,6 @@
                 <a:cs typeface="Be Vietnam Pro" pitchFamily="34" charset="-120"/>
               </a:rPr>
               <a:t> tệp</a:t>
-            </a:r>
-            <a:r>
-              <a:rPr lang="en-US" sz="2850" b="1" dirty="0" spc="6" kern="0">
-                <a:solidFill>
-                  <a:srgbClr val="F3EEE3"/>
-                </a:solidFill>
-                <a:latin typeface="Be Vietnam Pro" pitchFamily="34" charset="0"/>
-                <a:ea typeface="Be Vietnam Pro" pitchFamily="34" charset="-122"/>
-                <a:cs typeface="Be Vietnam Pro" pitchFamily="34" charset="-120"/>
-              </a:rPr>
-              <a:t> mới</a:t>
             </a:r>
             <a:endParaRPr lang="en-US" sz="2850" dirty="0"/>
           </a:p>

</xml_diff>

<commit_message>
sd-02-029: the hotspot is a Discord server's hot data on its replica set, not one machine owning the channel
Co-Authored-By: Claude Opus 5.5 <noreply@anthropic.com>
Claude-Session: https://claude.ai/code/session_01McBLtMnJbTnB94NeVs8a2V
</commit_message>
<xml_diff>
--- a/system-design-101/vi/lessons/sd-02-029/slides/sd-02-029.pptx
+++ b/system-design-101/vi/lessons/sd-02-029/slides/sd-02-029.pptx
@@ -7643,7 +7643,7 @@
               <a:t> một</a:t>
             </a:r>
             <a:r>
-              <a:rPr lang="en-US" sz="3900" dirty="0" spc="5" kern="0">
+              <a:rPr lang="en-US" sz="3900" dirty="0" spc="3" kern="0">
                 <a:solidFill>
                   <a:srgbClr val="14161C"/>
                 </a:solidFill>
@@ -7651,7 +7651,7 @@
                 <a:ea typeface="Bricolage Grotesque ExtraBold" pitchFamily="34" charset="-122"/>
                 <a:cs typeface="Bricolage Grotesque ExtraBold" pitchFamily="34" charset="-120"/>
               </a:rPr>
-              <a:t> máy</a:t>
+              <a:t> chỗ</a:t>
             </a:r>
             <a:endParaRPr lang="en-US" sz="3900" dirty="0"/>
           </a:p>
@@ -12172,7 +12172,7 @@
               <a:t> một</a:t>
             </a:r>
             <a:r>
-              <a:rPr lang="en-US" sz="2700" dirty="0" spc="-10" kern="0">
+              <a:rPr lang="en-US" sz="2700" dirty="0" spc="-1" kern="0">
                 <a:solidFill>
                   <a:srgbClr val="14161C"/>
                 </a:solidFill>
@@ -12180,7 +12180,7 @@
                 <a:ea typeface="Be Vietnam Pro" pitchFamily="34" charset="-122"/>
                 <a:cs typeface="Be Vietnam Pro" pitchFamily="34" charset="-120"/>
               </a:rPr>
-              <a:t> máy.</a:t>
+              <a:t> chỗ.</a:t>
             </a:r>
             <a:endParaRPr lang="en-US" sz="2700" dirty="0"/>
           </a:p>

</xml_diff>